<commit_message>
Update SENTINEL-GNSS and proposal presentation slides
</commit_message>
<xml_diff>
--- a/proposal/Presentations/GNSS_Proposal_Presentation.pptx
+++ b/proposal/Presentations/GNSS_Proposal_Presentation.pptx
@@ -128,7 +128,7 @@
   </p:defaultTextStyle>
   <p:extLst>
     <p:ext uri="{EFAFB233-063F-42B5-8137-9DF3F51BA10A}">
-      <p15:sldGuideLst xmlns:p15="http://schemas.microsoft.com/office/powerpoint/2012/main"/>
+      <p15:sldGuideLst xmlns:p15="http://schemas.microsoft.com/office/powerpoint/2012/main" xmlns=""/>
     </p:ext>
   </p:extLst>
 </p:presentation>
@@ -1023,7 +1023,7 @@
         <p:cNvPr id="1" name="">
           <a:extLst>
             <a:ext uri="{FF2B5EF4-FFF2-40B4-BE49-F238E27FC236}">
-              <a16:creationId xmlns:a16="http://schemas.microsoft.com/office/drawing/2014/main" id="{76E4654F-C4B8-973C-4F3A-69EDD28608E5}"/>
+              <a16:creationId xmlns:a16="http://schemas.microsoft.com/office/drawing/2014/main" xmlns="" id="{76E4654F-C4B8-973C-4F3A-69EDD28608E5}"/>
             </a:ext>
           </a:extLst>
         </p:cNvPr>
@@ -1043,7 +1043,7 @@
           <p:cNvPr id="2" name="Slide Image Placeholder 1">
             <a:extLst>
               <a:ext uri="{FF2B5EF4-FFF2-40B4-BE49-F238E27FC236}">
-                <a16:creationId xmlns:a16="http://schemas.microsoft.com/office/drawing/2014/main" id="{EA1BAC86-B467-7F81-A1D4-FA68E2E3E16F}"/>
+                <a16:creationId xmlns:a16="http://schemas.microsoft.com/office/drawing/2014/main" xmlns="" id="{EA1BAC86-B467-7F81-A1D4-FA68E2E3E16F}"/>
               </a:ext>
             </a:extLst>
           </p:cNvPr>
@@ -1061,7 +1061,7 @@
           <p:cNvPr id="3" name="Notes Placeholder 2">
             <a:extLst>
               <a:ext uri="{FF2B5EF4-FFF2-40B4-BE49-F238E27FC236}">
-                <a16:creationId xmlns:a16="http://schemas.microsoft.com/office/drawing/2014/main" id="{DE3A5620-5F8F-1825-C028-7E051149D1CE}"/>
+                <a16:creationId xmlns:a16="http://schemas.microsoft.com/office/drawing/2014/main" xmlns="" id="{DE3A5620-5F8F-1825-C028-7E051149D1CE}"/>
               </a:ext>
             </a:extLst>
           </p:cNvPr>
@@ -1086,7 +1086,7 @@
           <p:cNvPr id="4" name="Slide Number Placeholder 3">
             <a:extLst>
               <a:ext uri="{FF2B5EF4-FFF2-40B4-BE49-F238E27FC236}">
-                <a16:creationId xmlns:a16="http://schemas.microsoft.com/office/drawing/2014/main" id="{456720D3-B57C-30A7-0C49-941F2E642A9E}"/>
+                <a16:creationId xmlns:a16="http://schemas.microsoft.com/office/drawing/2014/main" xmlns="" id="{456720D3-B57C-30A7-0C49-941F2E642A9E}"/>
               </a:ext>
             </a:extLst>
           </p:cNvPr>
@@ -1719,7 +1719,7 @@
         <p:cNvPr id="1" name="">
           <a:extLst>
             <a:ext uri="{FF2B5EF4-FFF2-40B4-BE49-F238E27FC236}">
-              <a16:creationId xmlns:a16="http://schemas.microsoft.com/office/drawing/2014/main" id="{D588DCF2-868A-563F-4963-2235003E8989}"/>
+              <a16:creationId xmlns:a16="http://schemas.microsoft.com/office/drawing/2014/main" xmlns="" id="{D588DCF2-868A-563F-4963-2235003E8989}"/>
             </a:ext>
           </a:extLst>
         </p:cNvPr>
@@ -1739,7 +1739,7 @@
           <p:cNvPr id="2" name="Slide Image Placeholder 1">
             <a:extLst>
               <a:ext uri="{FF2B5EF4-FFF2-40B4-BE49-F238E27FC236}">
-                <a16:creationId xmlns:a16="http://schemas.microsoft.com/office/drawing/2014/main" id="{BE7E8E8A-24AA-91B2-5AC6-4E69D12B059F}"/>
+                <a16:creationId xmlns:a16="http://schemas.microsoft.com/office/drawing/2014/main" xmlns="" id="{BE7E8E8A-24AA-91B2-5AC6-4E69D12B059F}"/>
               </a:ext>
             </a:extLst>
           </p:cNvPr>
@@ -1757,7 +1757,7 @@
           <p:cNvPr id="3" name="Notes Placeholder 2">
             <a:extLst>
               <a:ext uri="{FF2B5EF4-FFF2-40B4-BE49-F238E27FC236}">
-                <a16:creationId xmlns:a16="http://schemas.microsoft.com/office/drawing/2014/main" id="{D8DE93A1-090C-ABBA-115E-0071A7149BDC}"/>
+                <a16:creationId xmlns:a16="http://schemas.microsoft.com/office/drawing/2014/main" xmlns="" id="{D8DE93A1-090C-ABBA-115E-0071A7149BDC}"/>
               </a:ext>
             </a:extLst>
           </p:cNvPr>
@@ -1782,7 +1782,7 @@
           <p:cNvPr id="4" name="Slide Number Placeholder 3">
             <a:extLst>
               <a:ext uri="{FF2B5EF4-FFF2-40B4-BE49-F238E27FC236}">
-                <a16:creationId xmlns:a16="http://schemas.microsoft.com/office/drawing/2014/main" id="{68BE0718-60EE-9A04-9800-53CC11DE1E0D}"/>
+                <a16:creationId xmlns:a16="http://schemas.microsoft.com/office/drawing/2014/main" xmlns="" id="{68BE0718-60EE-9A04-9800-53CC11DE1E0D}"/>
               </a:ext>
             </a:extLst>
           </p:cNvPr>
@@ -2163,7 +2163,7 @@
         <p:cNvPr id="1" name="">
           <a:extLst>
             <a:ext uri="{FF2B5EF4-FFF2-40B4-BE49-F238E27FC236}">
-              <a16:creationId xmlns:a16="http://schemas.microsoft.com/office/drawing/2014/main" id="{6EC85914-34FA-09E6-C316-015610808C16}"/>
+              <a16:creationId xmlns:a16="http://schemas.microsoft.com/office/drawing/2014/main" xmlns="" id="{6EC85914-34FA-09E6-C316-015610808C16}"/>
             </a:ext>
           </a:extLst>
         </p:cNvPr>
@@ -2183,7 +2183,7 @@
           <p:cNvPr id="2" name="Slide Image Placeholder 1">
             <a:extLst>
               <a:ext uri="{FF2B5EF4-FFF2-40B4-BE49-F238E27FC236}">
-                <a16:creationId xmlns:a16="http://schemas.microsoft.com/office/drawing/2014/main" id="{C76C0FE3-96DB-DE33-2FD2-B190C3907333}"/>
+                <a16:creationId xmlns:a16="http://schemas.microsoft.com/office/drawing/2014/main" xmlns="" id="{C76C0FE3-96DB-DE33-2FD2-B190C3907333}"/>
               </a:ext>
             </a:extLst>
           </p:cNvPr>
@@ -2201,7 +2201,7 @@
           <p:cNvPr id="3" name="Notes Placeholder 2">
             <a:extLst>
               <a:ext uri="{FF2B5EF4-FFF2-40B4-BE49-F238E27FC236}">
-                <a16:creationId xmlns:a16="http://schemas.microsoft.com/office/drawing/2014/main" id="{FECAC537-3D7C-B62A-F6CF-AA9881F8E16E}"/>
+                <a16:creationId xmlns:a16="http://schemas.microsoft.com/office/drawing/2014/main" xmlns="" id="{FECAC537-3D7C-B62A-F6CF-AA9881F8E16E}"/>
               </a:ext>
             </a:extLst>
           </p:cNvPr>
@@ -2226,7 +2226,7 @@
           <p:cNvPr id="4" name="Slide Number Placeholder 3">
             <a:extLst>
               <a:ext uri="{FF2B5EF4-FFF2-40B4-BE49-F238E27FC236}">
-                <a16:creationId xmlns:a16="http://schemas.microsoft.com/office/drawing/2014/main" id="{583BBB20-83D3-DBED-2493-E03449B6008E}"/>
+                <a16:creationId xmlns:a16="http://schemas.microsoft.com/office/drawing/2014/main" xmlns="" id="{583BBB20-83D3-DBED-2493-E03449B6008E}"/>
               </a:ext>
             </a:extLst>
           </p:cNvPr>
@@ -2753,21 +2753,21 @@
                 <a:gridCol w="669235">
                   <a:extLst>
                     <a:ext uri="{9D8B030D-6E8A-4147-A177-3AD203B41FA5}">
-                      <a16:colId xmlns:a16="http://schemas.microsoft.com/office/drawing/2014/main" val="20000"/>
+                      <a16:colId xmlns:a16="http://schemas.microsoft.com/office/drawing/2014/main" xmlns="" val="20000"/>
                     </a:ext>
                   </a:extLst>
                 </a:gridCol>
                 <a:gridCol w="4908605">
                   <a:extLst>
                     <a:ext uri="{9D8B030D-6E8A-4147-A177-3AD203B41FA5}">
-                      <a16:colId xmlns:a16="http://schemas.microsoft.com/office/drawing/2014/main" val="20001"/>
+                      <a16:colId xmlns:a16="http://schemas.microsoft.com/office/drawing/2014/main" xmlns="" val="20001"/>
                     </a:ext>
                   </a:extLst>
                 </a:gridCol>
                 <a:gridCol w="2286000">
                   <a:extLst>
                     <a:ext uri="{9D8B030D-6E8A-4147-A177-3AD203B41FA5}">
-                      <a16:colId xmlns:a16="http://schemas.microsoft.com/office/drawing/2014/main" val="20002"/>
+                      <a16:colId xmlns:a16="http://schemas.microsoft.com/office/drawing/2014/main" xmlns="" val="20002"/>
                     </a:ext>
                   </a:extLst>
                 </a:gridCol>
@@ -2979,7 +2979,7 @@
                 </a:tc>
                 <a:extLst>
                   <a:ext uri="{0D108BD9-81ED-4DB2-BD59-A6C34878D82A}">
-                    <a16:rowId xmlns:a16="http://schemas.microsoft.com/office/drawing/2014/main" val="10000"/>
+                    <a16:rowId xmlns:a16="http://schemas.microsoft.com/office/drawing/2014/main" xmlns="" val="10000"/>
                   </a:ext>
                 </a:extLst>
               </a:tr>
@@ -3190,7 +3190,7 @@
                 </a:tc>
                 <a:extLst>
                   <a:ext uri="{0D108BD9-81ED-4DB2-BD59-A6C34878D82A}">
-                    <a16:rowId xmlns:a16="http://schemas.microsoft.com/office/drawing/2014/main" val="10001"/>
+                    <a16:rowId xmlns:a16="http://schemas.microsoft.com/office/drawing/2014/main" xmlns="" val="10001"/>
                   </a:ext>
                 </a:extLst>
               </a:tr>
@@ -3401,7 +3401,7 @@
                 </a:tc>
                 <a:extLst>
                   <a:ext uri="{0D108BD9-81ED-4DB2-BD59-A6C34878D82A}">
-                    <a16:rowId xmlns:a16="http://schemas.microsoft.com/office/drawing/2014/main" val="10002"/>
+                    <a16:rowId xmlns:a16="http://schemas.microsoft.com/office/drawing/2014/main" xmlns="" val="10002"/>
                   </a:ext>
                 </a:extLst>
               </a:tr>
@@ -3626,7 +3626,7 @@
                 </a:tc>
                 <a:extLst>
                   <a:ext uri="{0D108BD9-81ED-4DB2-BD59-A6C34878D82A}">
-                    <a16:rowId xmlns:a16="http://schemas.microsoft.com/office/drawing/2014/main" val="10003"/>
+                    <a16:rowId xmlns:a16="http://schemas.microsoft.com/office/drawing/2014/main" xmlns="" val="10003"/>
                   </a:ext>
                 </a:extLst>
               </a:tr>
@@ -3837,7 +3837,7 @@
                 </a:tc>
                 <a:extLst>
                   <a:ext uri="{0D108BD9-81ED-4DB2-BD59-A6C34878D82A}">
-                    <a16:rowId xmlns:a16="http://schemas.microsoft.com/office/drawing/2014/main" val="10004"/>
+                    <a16:rowId xmlns:a16="http://schemas.microsoft.com/office/drawing/2014/main" xmlns="" val="10004"/>
                   </a:ext>
                 </a:extLst>
               </a:tr>
@@ -4048,7 +4048,7 @@
                 </a:tc>
                 <a:extLst>
                   <a:ext uri="{0D108BD9-81ED-4DB2-BD59-A6C34878D82A}">
-                    <a16:rowId xmlns:a16="http://schemas.microsoft.com/office/drawing/2014/main" val="10005"/>
+                    <a16:rowId xmlns:a16="http://schemas.microsoft.com/office/drawing/2014/main" xmlns="" val="10005"/>
                   </a:ext>
                 </a:extLst>
               </a:tr>
@@ -4061,7 +4061,7 @@
           <p:cNvPr id="6" name="Rectangle 5">
             <a:extLst>
               <a:ext uri="{FF2B5EF4-FFF2-40B4-BE49-F238E27FC236}">
-                <a16:creationId xmlns:a16="http://schemas.microsoft.com/office/drawing/2014/main" id="{E77A5688-5D3D-76CB-DF27-D06D55042F3B}"/>
+                <a16:creationId xmlns:a16="http://schemas.microsoft.com/office/drawing/2014/main" xmlns="" id="{E77A5688-5D3D-76CB-DF27-D06D55042F3B}"/>
               </a:ext>
             </a:extLst>
           </p:cNvPr>
@@ -5831,8 +5831,8 @@
         </p:nvSpPr>
         <p:spPr>
           <a:xfrm>
-            <a:off x="457200" y="2606040"/>
-            <a:ext cx="8229600" cy="594360"/>
+            <a:off x="457200" y="2603196"/>
+            <a:ext cx="8229600" cy="597204"/>
           </a:xfrm>
           <a:prstGeom prst="rect">
             <a:avLst/>
@@ -8637,21 +8637,21 @@
                 <a:gridCol w="1463040">
                   <a:extLst>
                     <a:ext uri="{9D8B030D-6E8A-4147-A177-3AD203B41FA5}">
-                      <a16:colId xmlns:a16="http://schemas.microsoft.com/office/drawing/2014/main" val="20000"/>
+                      <a16:colId xmlns:a16="http://schemas.microsoft.com/office/drawing/2014/main" xmlns="" val="20000"/>
                     </a:ext>
                   </a:extLst>
                 </a:gridCol>
                 <a:gridCol w="2011680">
                   <a:extLst>
                     <a:ext uri="{9D8B030D-6E8A-4147-A177-3AD203B41FA5}">
-                      <a16:colId xmlns:a16="http://schemas.microsoft.com/office/drawing/2014/main" val="20001"/>
+                      <a16:colId xmlns:a16="http://schemas.microsoft.com/office/drawing/2014/main" xmlns="" val="20001"/>
                     </a:ext>
                   </a:extLst>
                 </a:gridCol>
                 <a:gridCol w="4754880">
                   <a:extLst>
                     <a:ext uri="{9D8B030D-6E8A-4147-A177-3AD203B41FA5}">
-                      <a16:colId xmlns:a16="http://schemas.microsoft.com/office/drawing/2014/main" val="20002"/>
+                      <a16:colId xmlns:a16="http://schemas.microsoft.com/office/drawing/2014/main" xmlns="" val="20002"/>
                     </a:ext>
                   </a:extLst>
                 </a:gridCol>
@@ -8863,7 +8863,7 @@
                 </a:tc>
                 <a:extLst>
                   <a:ext uri="{0D108BD9-81ED-4DB2-BD59-A6C34878D82A}">
-                    <a16:rowId xmlns:a16="http://schemas.microsoft.com/office/drawing/2014/main" val="10000"/>
+                    <a16:rowId xmlns:a16="http://schemas.microsoft.com/office/drawing/2014/main" xmlns="" val="10000"/>
                   </a:ext>
                 </a:extLst>
               </a:tr>
@@ -9065,7 +9065,7 @@
                 </a:tc>
                 <a:extLst>
                   <a:ext uri="{0D108BD9-81ED-4DB2-BD59-A6C34878D82A}">
-                    <a16:rowId xmlns:a16="http://schemas.microsoft.com/office/drawing/2014/main" val="10001"/>
+                    <a16:rowId xmlns:a16="http://schemas.microsoft.com/office/drawing/2014/main" xmlns="" val="10001"/>
                   </a:ext>
                 </a:extLst>
               </a:tr>
@@ -9267,7 +9267,7 @@
                 </a:tc>
                 <a:extLst>
                   <a:ext uri="{0D108BD9-81ED-4DB2-BD59-A6C34878D82A}">
-                    <a16:rowId xmlns:a16="http://schemas.microsoft.com/office/drawing/2014/main" val="10002"/>
+                    <a16:rowId xmlns:a16="http://schemas.microsoft.com/office/drawing/2014/main" xmlns="" val="10002"/>
                   </a:ext>
                 </a:extLst>
               </a:tr>
@@ -9469,7 +9469,7 @@
                 </a:tc>
                 <a:extLst>
                   <a:ext uri="{0D108BD9-81ED-4DB2-BD59-A6C34878D82A}">
-                    <a16:rowId xmlns:a16="http://schemas.microsoft.com/office/drawing/2014/main" val="10003"/>
+                    <a16:rowId xmlns:a16="http://schemas.microsoft.com/office/drawing/2014/main" xmlns="" val="10003"/>
                   </a:ext>
                 </a:extLst>
               </a:tr>
@@ -9671,7 +9671,7 @@
                 </a:tc>
                 <a:extLst>
                   <a:ext uri="{0D108BD9-81ED-4DB2-BD59-A6C34878D82A}">
-                    <a16:rowId xmlns:a16="http://schemas.microsoft.com/office/drawing/2014/main" val="10004"/>
+                    <a16:rowId xmlns:a16="http://schemas.microsoft.com/office/drawing/2014/main" xmlns="" val="10004"/>
                   </a:ext>
                 </a:extLst>
               </a:tr>
@@ -10384,7 +10384,7 @@
         </p:nvGraphicFramePr>
         <p:xfrm>
           <a:off x="457200" y="1059180"/>
-          <a:ext cx="8229600" cy="2255520"/>
+          <a:ext cx="8229600" cy="2418588"/>
         </p:xfrm>
         <a:graphic>
           <a:graphicData uri="http://schemas.openxmlformats.org/drawingml/2006/table">
@@ -10394,14 +10394,14 @@
                 <a:gridCol w="3200400">
                   <a:extLst>
                     <a:ext uri="{9D8B030D-6E8A-4147-A177-3AD203B41FA5}">
-                      <a16:colId xmlns:a16="http://schemas.microsoft.com/office/drawing/2014/main" val="20000"/>
+                      <a16:colId xmlns:a16="http://schemas.microsoft.com/office/drawing/2014/main" xmlns="" val="20000"/>
                     </a:ext>
                   </a:extLst>
                 </a:gridCol>
                 <a:gridCol w="5029200">
                   <a:extLst>
                     <a:ext uri="{9D8B030D-6E8A-4147-A177-3AD203B41FA5}">
-                      <a16:colId xmlns:a16="http://schemas.microsoft.com/office/drawing/2014/main" val="20001"/>
+                      <a16:colId xmlns:a16="http://schemas.microsoft.com/office/drawing/2014/main" xmlns="" val="20001"/>
                     </a:ext>
                   </a:extLst>
                 </a:gridCol>
@@ -10545,7 +10545,7 @@
                 </a:tc>
                 <a:extLst>
                   <a:ext uri="{0D108BD9-81ED-4DB2-BD59-A6C34878D82A}">
-                    <a16:rowId xmlns:a16="http://schemas.microsoft.com/office/drawing/2014/main" val="10000"/>
+                    <a16:rowId xmlns:a16="http://schemas.microsoft.com/office/drawing/2014/main" xmlns="" val="10000"/>
                   </a:ext>
                 </a:extLst>
               </a:tr>
@@ -10688,7 +10688,7 @@
                 </a:tc>
                 <a:extLst>
                   <a:ext uri="{0D108BD9-81ED-4DB2-BD59-A6C34878D82A}">
-                    <a16:rowId xmlns:a16="http://schemas.microsoft.com/office/drawing/2014/main" val="10001"/>
+                    <a16:rowId xmlns:a16="http://schemas.microsoft.com/office/drawing/2014/main" xmlns="" val="10001"/>
                   </a:ext>
                 </a:extLst>
               </a:tr>
@@ -10831,7 +10831,7 @@
                 </a:tc>
                 <a:extLst>
                   <a:ext uri="{0D108BD9-81ED-4DB2-BD59-A6C34878D82A}">
-                    <a16:rowId xmlns:a16="http://schemas.microsoft.com/office/drawing/2014/main" val="10002"/>
+                    <a16:rowId xmlns:a16="http://schemas.microsoft.com/office/drawing/2014/main" xmlns="" val="10002"/>
                   </a:ext>
                 </a:extLst>
               </a:tr>
@@ -10974,7 +10974,7 @@
                 </a:tc>
                 <a:extLst>
                   <a:ext uri="{0D108BD9-81ED-4DB2-BD59-A6C34878D82A}">
-                    <a16:rowId xmlns:a16="http://schemas.microsoft.com/office/drawing/2014/main" val="10003"/>
+                    <a16:rowId xmlns:a16="http://schemas.microsoft.com/office/drawing/2014/main" xmlns="" val="10003"/>
                   </a:ext>
                 </a:extLst>
               </a:tr>
@@ -11117,7 +11117,7 @@
                 </a:tc>
                 <a:extLst>
                   <a:ext uri="{0D108BD9-81ED-4DB2-BD59-A6C34878D82A}">
-                    <a16:rowId xmlns:a16="http://schemas.microsoft.com/office/drawing/2014/main" val="10004"/>
+                    <a16:rowId xmlns:a16="http://schemas.microsoft.com/office/drawing/2014/main" xmlns="" val="10004"/>
                   </a:ext>
                 </a:extLst>
               </a:tr>
@@ -11260,7 +11260,7 @@
                 </a:tc>
                 <a:extLst>
                   <a:ext uri="{0D108BD9-81ED-4DB2-BD59-A6C34878D82A}">
-                    <a16:rowId xmlns:a16="http://schemas.microsoft.com/office/drawing/2014/main" val="10005"/>
+                    <a16:rowId xmlns:a16="http://schemas.microsoft.com/office/drawing/2014/main" xmlns="" val="10005"/>
                   </a:ext>
                 </a:extLst>
               </a:tr>
@@ -11403,7 +11403,7 @@
                 </a:tc>
                 <a:extLst>
                   <a:ext uri="{0D108BD9-81ED-4DB2-BD59-A6C34878D82A}">
-                    <a16:rowId xmlns:a16="http://schemas.microsoft.com/office/drawing/2014/main" val="10006"/>
+                    <a16:rowId xmlns:a16="http://schemas.microsoft.com/office/drawing/2014/main" xmlns="" val="10006"/>
                   </a:ext>
                 </a:extLst>
               </a:tr>
@@ -11785,21 +11785,21 @@
                 <a:gridCol w="2286000">
                   <a:extLst>
                     <a:ext uri="{9D8B030D-6E8A-4147-A177-3AD203B41FA5}">
-                      <a16:colId xmlns:a16="http://schemas.microsoft.com/office/drawing/2014/main" val="20000"/>
+                      <a16:colId xmlns:a16="http://schemas.microsoft.com/office/drawing/2014/main" xmlns="" val="20000"/>
                     </a:ext>
                   </a:extLst>
                 </a:gridCol>
                 <a:gridCol w="2743200">
                   <a:extLst>
                     <a:ext uri="{9D8B030D-6E8A-4147-A177-3AD203B41FA5}">
-                      <a16:colId xmlns:a16="http://schemas.microsoft.com/office/drawing/2014/main" val="20001"/>
+                      <a16:colId xmlns:a16="http://schemas.microsoft.com/office/drawing/2014/main" xmlns="" val="20001"/>
                     </a:ext>
                   </a:extLst>
                 </a:gridCol>
                 <a:gridCol w="3200400">
                   <a:extLst>
                     <a:ext uri="{9D8B030D-6E8A-4147-A177-3AD203B41FA5}">
-                      <a16:colId xmlns:a16="http://schemas.microsoft.com/office/drawing/2014/main" val="20002"/>
+                      <a16:colId xmlns:a16="http://schemas.microsoft.com/office/drawing/2014/main" xmlns="" val="20002"/>
                     </a:ext>
                   </a:extLst>
                 </a:gridCol>
@@ -12011,7 +12011,7 @@
                 </a:tc>
                 <a:extLst>
                   <a:ext uri="{0D108BD9-81ED-4DB2-BD59-A6C34878D82A}">
-                    <a16:rowId xmlns:a16="http://schemas.microsoft.com/office/drawing/2014/main" val="10000"/>
+                    <a16:rowId xmlns:a16="http://schemas.microsoft.com/office/drawing/2014/main" xmlns="" val="10000"/>
                   </a:ext>
                 </a:extLst>
               </a:tr>
@@ -12213,7 +12213,7 @@
                 </a:tc>
                 <a:extLst>
                   <a:ext uri="{0D108BD9-81ED-4DB2-BD59-A6C34878D82A}">
-                    <a16:rowId xmlns:a16="http://schemas.microsoft.com/office/drawing/2014/main" val="10001"/>
+                    <a16:rowId xmlns:a16="http://schemas.microsoft.com/office/drawing/2014/main" xmlns="" val="10001"/>
                   </a:ext>
                 </a:extLst>
               </a:tr>
@@ -12415,7 +12415,7 @@
                 </a:tc>
                 <a:extLst>
                   <a:ext uri="{0D108BD9-81ED-4DB2-BD59-A6C34878D82A}">
-                    <a16:rowId xmlns:a16="http://schemas.microsoft.com/office/drawing/2014/main" val="10002"/>
+                    <a16:rowId xmlns:a16="http://schemas.microsoft.com/office/drawing/2014/main" xmlns="" val="10002"/>
                   </a:ext>
                 </a:extLst>
               </a:tr>
@@ -12617,7 +12617,7 @@
                 </a:tc>
                 <a:extLst>
                   <a:ext uri="{0D108BD9-81ED-4DB2-BD59-A6C34878D82A}">
-                    <a16:rowId xmlns:a16="http://schemas.microsoft.com/office/drawing/2014/main" val="10003"/>
+                    <a16:rowId xmlns:a16="http://schemas.microsoft.com/office/drawing/2014/main" xmlns="" val="10003"/>
                   </a:ext>
                 </a:extLst>
               </a:tr>
@@ -12819,7 +12819,7 @@
                 </a:tc>
                 <a:extLst>
                   <a:ext uri="{0D108BD9-81ED-4DB2-BD59-A6C34878D82A}">
-                    <a16:rowId xmlns:a16="http://schemas.microsoft.com/office/drawing/2014/main" val="10004"/>
+                    <a16:rowId xmlns:a16="http://schemas.microsoft.com/office/drawing/2014/main" xmlns="" val="10004"/>
                   </a:ext>
                 </a:extLst>
               </a:tr>
@@ -13021,7 +13021,7 @@
                 </a:tc>
                 <a:extLst>
                   <a:ext uri="{0D108BD9-81ED-4DB2-BD59-A6C34878D82A}">
-                    <a16:rowId xmlns:a16="http://schemas.microsoft.com/office/drawing/2014/main" val="10005"/>
+                    <a16:rowId xmlns:a16="http://schemas.microsoft.com/office/drawing/2014/main" xmlns="" val="10005"/>
                   </a:ext>
                 </a:extLst>
               </a:tr>
@@ -14273,7 +14273,7 @@
         <p:cNvPr id="1" name="">
           <a:extLst>
             <a:ext uri="{FF2B5EF4-FFF2-40B4-BE49-F238E27FC236}">
-              <a16:creationId xmlns:a16="http://schemas.microsoft.com/office/drawing/2014/main" id="{54609A8E-214C-3CF2-14F4-86A350628E82}"/>
+              <a16:creationId xmlns:a16="http://schemas.microsoft.com/office/drawing/2014/main" xmlns="" id="{54609A8E-214C-3CF2-14F4-86A350628E82}"/>
             </a:ext>
           </a:extLst>
         </p:cNvPr>
@@ -14293,7 +14293,7 @@
           <p:cNvPr id="2" name="Shape 0">
             <a:extLst>
               <a:ext uri="{FF2B5EF4-FFF2-40B4-BE49-F238E27FC236}">
-                <a16:creationId xmlns:a16="http://schemas.microsoft.com/office/drawing/2014/main" id="{AF58F401-729A-83D3-E625-39CB67F73B74}"/>
+                <a16:creationId xmlns:a16="http://schemas.microsoft.com/office/drawing/2014/main" xmlns="" id="{AF58F401-729A-83D3-E625-39CB67F73B74}"/>
               </a:ext>
             </a:extLst>
           </p:cNvPr>
@@ -14331,7 +14331,7 @@
           <p:cNvPr id="3" name="Text 1">
             <a:extLst>
               <a:ext uri="{FF2B5EF4-FFF2-40B4-BE49-F238E27FC236}">
-                <a16:creationId xmlns:a16="http://schemas.microsoft.com/office/drawing/2014/main" id="{19556145-DA88-10A0-C96A-33BA98254438}"/>
+                <a16:creationId xmlns:a16="http://schemas.microsoft.com/office/drawing/2014/main" xmlns="" id="{19556145-DA88-10A0-C96A-33BA98254438}"/>
               </a:ext>
             </a:extLst>
           </p:cNvPr>
@@ -14376,7 +14376,7 @@
           <p:cNvPr id="4" name="Text 2">
             <a:extLst>
               <a:ext uri="{FF2B5EF4-FFF2-40B4-BE49-F238E27FC236}">
-                <a16:creationId xmlns:a16="http://schemas.microsoft.com/office/drawing/2014/main" id="{7112CA0F-254F-5997-5B5B-9FEC5B5670E4}"/>
+                <a16:creationId xmlns:a16="http://schemas.microsoft.com/office/drawing/2014/main" xmlns="" id="{7112CA0F-254F-5997-5B5B-9FEC5B5670E4}"/>
               </a:ext>
             </a:extLst>
           </p:cNvPr>
@@ -14410,7 +14410,7 @@
           <p:cNvPr id="5" name="Shape 3">
             <a:extLst>
               <a:ext uri="{FF2B5EF4-FFF2-40B4-BE49-F238E27FC236}">
-                <a16:creationId xmlns:a16="http://schemas.microsoft.com/office/drawing/2014/main" id="{55500F85-65B4-0AAC-1A05-CB9EB0EE44CA}"/>
+                <a16:creationId xmlns:a16="http://schemas.microsoft.com/office/drawing/2014/main" xmlns="" id="{55500F85-65B4-0AAC-1A05-CB9EB0EE44CA}"/>
               </a:ext>
             </a:extLst>
           </p:cNvPr>
@@ -14448,7 +14448,7 @@
           <p:cNvPr id="33" name="Picture 32">
             <a:extLst>
               <a:ext uri="{FF2B5EF4-FFF2-40B4-BE49-F238E27FC236}">
-                <a16:creationId xmlns:a16="http://schemas.microsoft.com/office/drawing/2014/main" id="{D1CA55FF-324D-F32C-73FD-20E42B8D5FED}"/>
+                <a16:creationId xmlns:a16="http://schemas.microsoft.com/office/drawing/2014/main" xmlns="" id="{D1CA55FF-324D-F32C-73FD-20E42B8D5FED}"/>
               </a:ext>
             </a:extLst>
           </p:cNvPr>
@@ -14774,7 +14774,7 @@
                                   <a:lumMod val="50000"/>
                                 </a:schemeClr>
                               </a:solidFill>
-                              <a:latin typeface="Cambria Math" panose="02040503050406030204" pitchFamily="18" charset="0"/>
+                              <a:latin typeface="Cambria Math"/>
                             </a:rPr>
                           </m:ctrlPr>
                         </m:sSubPr>
@@ -14827,7 +14827,7 @@
                                   <a:lumMod val="50000"/>
                                 </a:schemeClr>
                               </a:solidFill>
-                              <a:latin typeface="Cambria Math" panose="02040503050406030204" pitchFamily="18" charset="0"/>
+                              <a:latin typeface="Cambria Math"/>
                             </a:rPr>
                           </m:ctrlPr>
                         </m:dPr>
@@ -14885,7 +14885,7 @@
                                       <a:lumMod val="50000"/>
                                     </a:schemeClr>
                                   </a:solidFill>
-                                  <a:latin typeface="Cambria Math" panose="02040503050406030204" pitchFamily="18" charset="0"/>
+                                  <a:latin typeface="Cambria Math"/>
                                 </a:rPr>
                               </m:ctrlPr>
                             </m:sSubPr>
@@ -15008,7 +15008,7 @@
                       <m:sSubPr>
                         <m:ctrlPr>
                           <a:rPr lang="ar-AE" sz="1200" b="1" i="1" smtClean="0">
-                            <a:latin typeface="Cambria Math" panose="02040503050406030204" pitchFamily="18" charset="0"/>
+                            <a:latin typeface="Cambria Math"/>
                           </a:rPr>
                         </m:ctrlPr>
                       </m:sSubPr>
@@ -15061,7 +15061,7 @@
                       <m:sSubPr>
                         <m:ctrlPr>
                           <a:rPr lang="ar-AE" sz="1200" b="1" i="1">
-                            <a:latin typeface="Cambria Math" panose="02040503050406030204" pitchFamily="18" charset="0"/>
+                            <a:latin typeface="Cambria Math"/>
                           </a:rPr>
                         </m:ctrlPr>
                       </m:sSubPr>
@@ -15117,7 +15117,13 @@
                       <a:rPr lang="en-US" sz="1200">
                         <a:latin typeface="Cambria Math" panose="02040503050406030204" pitchFamily="18" charset="0"/>
                       </a:rPr>
-                      <m:t>=10</m:t>
+                      <m:t>=</m:t>
+                    </m:r>
+                    <m:r>
+                      <a:rPr lang="en-US" sz="1200">
+                        <a:latin typeface="Cambria Math" panose="02040503050406030204" pitchFamily="18" charset="0"/>
+                      </a:rPr>
+                      <m:t>10</m:t>
                     </m:r>
                   </m:oMath>
                 </a14:m>
@@ -15239,7 +15245,7 @@
                       <m:sSubPr>
                         <m:ctrlPr>
                           <a:rPr lang="en-US" sz="1200" i="1">
-                            <a:latin typeface="Cambria Math" panose="02040503050406030204" pitchFamily="18" charset="0"/>
+                            <a:latin typeface="Cambria Math"/>
                           </a:rPr>
                         </m:ctrlPr>
                       </m:sSubPr>
@@ -15265,7 +15271,25 @@
                       <a:rPr lang="en-US" sz="1200">
                         <a:latin typeface="Cambria Math" panose="02040503050406030204" pitchFamily="18" charset="0"/>
                       </a:rPr>
-                      <m:t>=0.0</m:t>
+                      <m:t>=</m:t>
+                    </m:r>
+                    <m:r>
+                      <a:rPr lang="en-US" sz="1200">
+                        <a:latin typeface="Cambria Math" panose="02040503050406030204" pitchFamily="18" charset="0"/>
+                      </a:rPr>
+                      <m:t>0</m:t>
+                    </m:r>
+                    <m:r>
+                      <a:rPr lang="en-US" sz="1200">
+                        <a:latin typeface="Cambria Math" panose="02040503050406030204" pitchFamily="18" charset="0"/>
+                      </a:rPr>
+                      <m:t>.</m:t>
+                    </m:r>
+                    <m:r>
+                      <a:rPr lang="en-US" sz="1200">
+                        <a:latin typeface="Cambria Math" panose="02040503050406030204" pitchFamily="18" charset="0"/>
+                      </a:rPr>
+                      <m:t>0</m:t>
                     </m:r>
                     <m:r>
                       <a:rPr lang="en-US" sz="1200" i="1" smtClean="0">
@@ -15372,7 +15396,7 @@
                       <m:sSubPr>
                         <m:ctrlPr>
                           <a:rPr lang="en-US" sz="1200" i="1">
-                            <a:latin typeface="Cambria Math" panose="02040503050406030204" pitchFamily="18" charset="0"/>
+                            <a:latin typeface="Cambria Math"/>
                           </a:rPr>
                         </m:ctrlPr>
                       </m:sSubPr>
@@ -15544,7 +15568,7 @@
                       <m:sSubPr>
                         <m:ctrlPr>
                           <a:rPr lang="en-US" sz="1200" i="1">
-                            <a:latin typeface="Cambria Math" panose="02040503050406030204" pitchFamily="18" charset="0"/>
+                            <a:latin typeface="Cambria Math"/>
                           </a:rPr>
                         </m:ctrlPr>
                       </m:sSubPr>
@@ -15570,7 +15594,25 @@
                       <a:rPr lang="en-US" sz="1200">
                         <a:latin typeface="Cambria Math" panose="02040503050406030204" pitchFamily="18" charset="0"/>
                       </a:rPr>
-                      <m:t>=0.5</m:t>
+                      <m:t>=</m:t>
+                    </m:r>
+                    <m:r>
+                      <a:rPr lang="en-US" sz="1200">
+                        <a:latin typeface="Cambria Math" panose="02040503050406030204" pitchFamily="18" charset="0"/>
+                      </a:rPr>
+                      <m:t>0</m:t>
+                    </m:r>
+                    <m:r>
+                      <a:rPr lang="en-US" sz="1200">
+                        <a:latin typeface="Cambria Math" panose="02040503050406030204" pitchFamily="18" charset="0"/>
+                      </a:rPr>
+                      <m:t>.</m:t>
+                    </m:r>
+                    <m:r>
+                      <a:rPr lang="en-US" sz="1200">
+                        <a:latin typeface="Cambria Math" panose="02040503050406030204" pitchFamily="18" charset="0"/>
+                      </a:rPr>
+                      <m:t>5</m:t>
                     </m:r>
                   </m:oMath>
                 </a14:m>
@@ -15609,13 +15651,25 @@
                       <a:rPr lang="en-US" sz="1200">
                         <a:latin typeface="Cambria Math" panose="02040503050406030204" pitchFamily="18" charset="0"/>
                       </a:rPr>
-                      <m:t>=6×</m:t>
+                      <m:t>=</m:t>
+                    </m:r>
+                    <m:r>
+                      <a:rPr lang="en-US" sz="1200">
+                        <a:latin typeface="Cambria Math" panose="02040503050406030204" pitchFamily="18" charset="0"/>
+                      </a:rPr>
+                      <m:t>6</m:t>
+                    </m:r>
+                    <m:r>
+                      <a:rPr lang="en-US" sz="1200">
+                        <a:latin typeface="Cambria Math" panose="02040503050406030204" pitchFamily="18" charset="0"/>
+                      </a:rPr>
+                      <m:t>×</m:t>
                     </m:r>
                     <m:sSub>
                       <m:sSubPr>
                         <m:ctrlPr>
                           <a:rPr lang="en-US" sz="1200" i="1">
-                            <a:latin typeface="Cambria Math" panose="02040503050406030204" pitchFamily="18" charset="0"/>
+                            <a:latin typeface="Cambria Math"/>
                           </a:rPr>
                         </m:ctrlPr>
                       </m:sSubPr>
@@ -15799,7 +15853,7 @@
               <p:cNvPr id="20" name="Text 12">
                 <a:extLst>
                   <a:ext uri="{FF2B5EF4-FFF2-40B4-BE49-F238E27FC236}">
-                    <a16:creationId xmlns:a16="http://schemas.microsoft.com/office/drawing/2014/main" id="{8578BE49-A789-96A7-DD50-4D75B505CD2F}"/>
+                    <a16:creationId xmlns:a16="http://schemas.microsoft.com/office/drawing/2014/main" xmlns="" id="{8578BE49-A789-96A7-DD50-4D75B505CD2F}"/>
                   </a:ext>
                 </a:extLst>
               </p:cNvPr>
@@ -15832,7 +15886,7 @@
                       <m:sSubPr>
                         <m:ctrlPr>
                           <a:rPr lang="en-US" sz="1200" i="1" smtClean="0">
-                            <a:latin typeface="Cambria Math" panose="02040503050406030204" pitchFamily="18" charset="0"/>
+                            <a:latin typeface="Cambria Math"/>
                           </a:rPr>
                         </m:ctrlPr>
                       </m:sSubPr>
@@ -15858,7 +15912,19 @@
                       <a:rPr lang="en-US" sz="1200">
                         <a:latin typeface="Cambria Math" panose="02040503050406030204" pitchFamily="18" charset="0"/>
                       </a:rPr>
-                      <m:t>=0.</m:t>
+                      <m:t>=</m:t>
+                    </m:r>
+                    <m:r>
+                      <a:rPr lang="en-US" sz="1200">
+                        <a:latin typeface="Cambria Math" panose="02040503050406030204" pitchFamily="18" charset="0"/>
+                      </a:rPr>
+                      <m:t>0</m:t>
+                    </m:r>
+                    <m:r>
+                      <a:rPr lang="en-US" sz="1200">
+                        <a:latin typeface="Cambria Math" panose="02040503050406030204" pitchFamily="18" charset="0"/>
+                      </a:rPr>
+                      <m:t>.</m:t>
                     </m:r>
                     <m:r>
                       <a:rPr lang="en-US" sz="1200" b="0" i="0" smtClean="0">
@@ -15924,7 +15990,7 @@
                       <m:sSubPr>
                         <m:ctrlPr>
                           <a:rPr lang="en-US" sz="1200" i="1">
-                            <a:latin typeface="Cambria Math" panose="02040503050406030204" pitchFamily="18" charset="0"/>
+                            <a:latin typeface="Cambria Math"/>
                           </a:rPr>
                         </m:ctrlPr>
                       </m:sSubPr>
@@ -16198,14 +16264,14 @@
                 <a:gridCol w="457200">
                   <a:extLst>
                     <a:ext uri="{9D8B030D-6E8A-4147-A177-3AD203B41FA5}">
-                      <a16:colId xmlns:a16="http://schemas.microsoft.com/office/drawing/2014/main" val="20000"/>
+                      <a16:colId xmlns:a16="http://schemas.microsoft.com/office/drawing/2014/main" xmlns="" val="20000"/>
                     </a:ext>
                   </a:extLst>
                 </a:gridCol>
                 <a:gridCol w="3566160">
                   <a:extLst>
                     <a:ext uri="{9D8B030D-6E8A-4147-A177-3AD203B41FA5}">
-                      <a16:colId xmlns:a16="http://schemas.microsoft.com/office/drawing/2014/main" val="20001"/>
+                      <a16:colId xmlns:a16="http://schemas.microsoft.com/office/drawing/2014/main" xmlns="" val="20001"/>
                     </a:ext>
                   </a:extLst>
                 </a:gridCol>
@@ -16343,7 +16409,7 @@
                 </a:tc>
                 <a:extLst>
                   <a:ext uri="{0D108BD9-81ED-4DB2-BD59-A6C34878D82A}">
-                    <a16:rowId xmlns:a16="http://schemas.microsoft.com/office/drawing/2014/main" val="10000"/>
+                    <a16:rowId xmlns:a16="http://schemas.microsoft.com/office/drawing/2014/main" xmlns="" val="10000"/>
                   </a:ext>
                 </a:extLst>
               </a:tr>
@@ -16480,7 +16546,7 @@
                 </a:tc>
                 <a:extLst>
                   <a:ext uri="{0D108BD9-81ED-4DB2-BD59-A6C34878D82A}">
-                    <a16:rowId xmlns:a16="http://schemas.microsoft.com/office/drawing/2014/main" val="10001"/>
+                    <a16:rowId xmlns:a16="http://schemas.microsoft.com/office/drawing/2014/main" xmlns="" val="10001"/>
                   </a:ext>
                 </a:extLst>
               </a:tr>
@@ -16617,7 +16683,7 @@
                 </a:tc>
                 <a:extLst>
                   <a:ext uri="{0D108BD9-81ED-4DB2-BD59-A6C34878D82A}">
-                    <a16:rowId xmlns:a16="http://schemas.microsoft.com/office/drawing/2014/main" val="10002"/>
+                    <a16:rowId xmlns:a16="http://schemas.microsoft.com/office/drawing/2014/main" xmlns="" val="10002"/>
                   </a:ext>
                 </a:extLst>
               </a:tr>
@@ -16754,7 +16820,7 @@
                 </a:tc>
                 <a:extLst>
                   <a:ext uri="{0D108BD9-81ED-4DB2-BD59-A6C34878D82A}">
-                    <a16:rowId xmlns:a16="http://schemas.microsoft.com/office/drawing/2014/main" val="10003"/>
+                    <a16:rowId xmlns:a16="http://schemas.microsoft.com/office/drawing/2014/main" xmlns="" val="10003"/>
                   </a:ext>
                 </a:extLst>
               </a:tr>
@@ -16891,7 +16957,7 @@
                 </a:tc>
                 <a:extLst>
                   <a:ext uri="{0D108BD9-81ED-4DB2-BD59-A6C34878D82A}">
-                    <a16:rowId xmlns:a16="http://schemas.microsoft.com/office/drawing/2014/main" val="10004"/>
+                    <a16:rowId xmlns:a16="http://schemas.microsoft.com/office/drawing/2014/main" xmlns="" val="10004"/>
                   </a:ext>
                 </a:extLst>
               </a:tr>
@@ -17028,7 +17094,7 @@
                 </a:tc>
                 <a:extLst>
                   <a:ext uri="{0D108BD9-81ED-4DB2-BD59-A6C34878D82A}">
-                    <a16:rowId xmlns:a16="http://schemas.microsoft.com/office/drawing/2014/main" val="10005"/>
+                    <a16:rowId xmlns:a16="http://schemas.microsoft.com/office/drawing/2014/main" xmlns="" val="10005"/>
                   </a:ext>
                 </a:extLst>
               </a:tr>
@@ -17165,7 +17231,7 @@
                 </a:tc>
                 <a:extLst>
                   <a:ext uri="{0D108BD9-81ED-4DB2-BD59-A6C34878D82A}">
-                    <a16:rowId xmlns:a16="http://schemas.microsoft.com/office/drawing/2014/main" val="10006"/>
+                    <a16:rowId xmlns:a16="http://schemas.microsoft.com/office/drawing/2014/main" xmlns="" val="10006"/>
                   </a:ext>
                 </a:extLst>
               </a:tr>
@@ -17302,7 +17368,7 @@
                 </a:tc>
                 <a:extLst>
                   <a:ext uri="{0D108BD9-81ED-4DB2-BD59-A6C34878D82A}">
-                    <a16:rowId xmlns:a16="http://schemas.microsoft.com/office/drawing/2014/main" val="10007"/>
+                    <a16:rowId xmlns:a16="http://schemas.microsoft.com/office/drawing/2014/main" xmlns="" val="10007"/>
                   </a:ext>
                 </a:extLst>
               </a:tr>
@@ -17439,7 +17505,7 @@
                 </a:tc>
                 <a:extLst>
                   <a:ext uri="{0D108BD9-81ED-4DB2-BD59-A6C34878D82A}">
-                    <a16:rowId xmlns:a16="http://schemas.microsoft.com/office/drawing/2014/main" val="10008"/>
+                    <a16:rowId xmlns:a16="http://schemas.microsoft.com/office/drawing/2014/main" xmlns="" val="10008"/>
                   </a:ext>
                 </a:extLst>
               </a:tr>
@@ -17576,7 +17642,7 @@
                 </a:tc>
                 <a:extLst>
                   <a:ext uri="{0D108BD9-81ED-4DB2-BD59-A6C34878D82A}">
-                    <a16:rowId xmlns:a16="http://schemas.microsoft.com/office/drawing/2014/main" val="10009"/>
+                    <a16:rowId xmlns:a16="http://schemas.microsoft.com/office/drawing/2014/main" xmlns="" val="10009"/>
                   </a:ext>
                 </a:extLst>
               </a:tr>
@@ -17610,14 +17676,14 @@
                 <a:gridCol w="457200">
                   <a:extLst>
                     <a:ext uri="{9D8B030D-6E8A-4147-A177-3AD203B41FA5}">
-                      <a16:colId xmlns:a16="http://schemas.microsoft.com/office/drawing/2014/main" val="20000"/>
+                      <a16:colId xmlns:a16="http://schemas.microsoft.com/office/drawing/2014/main" xmlns="" val="20000"/>
                     </a:ext>
                   </a:extLst>
                 </a:gridCol>
                 <a:gridCol w="3566160">
                   <a:extLst>
                     <a:ext uri="{9D8B030D-6E8A-4147-A177-3AD203B41FA5}">
-                      <a16:colId xmlns:a16="http://schemas.microsoft.com/office/drawing/2014/main" val="20001"/>
+                      <a16:colId xmlns:a16="http://schemas.microsoft.com/office/drawing/2014/main" xmlns="" val="20001"/>
                     </a:ext>
                   </a:extLst>
                 </a:gridCol>
@@ -17755,7 +17821,7 @@
                 </a:tc>
                 <a:extLst>
                   <a:ext uri="{0D108BD9-81ED-4DB2-BD59-A6C34878D82A}">
-                    <a16:rowId xmlns:a16="http://schemas.microsoft.com/office/drawing/2014/main" val="10000"/>
+                    <a16:rowId xmlns:a16="http://schemas.microsoft.com/office/drawing/2014/main" xmlns="" val="10000"/>
                   </a:ext>
                 </a:extLst>
               </a:tr>
@@ -17892,7 +17958,7 @@
                 </a:tc>
                 <a:extLst>
                   <a:ext uri="{0D108BD9-81ED-4DB2-BD59-A6C34878D82A}">
-                    <a16:rowId xmlns:a16="http://schemas.microsoft.com/office/drawing/2014/main" val="10001"/>
+                    <a16:rowId xmlns:a16="http://schemas.microsoft.com/office/drawing/2014/main" xmlns="" val="10001"/>
                   </a:ext>
                 </a:extLst>
               </a:tr>
@@ -18029,7 +18095,7 @@
                 </a:tc>
                 <a:extLst>
                   <a:ext uri="{0D108BD9-81ED-4DB2-BD59-A6C34878D82A}">
-                    <a16:rowId xmlns:a16="http://schemas.microsoft.com/office/drawing/2014/main" val="10002"/>
+                    <a16:rowId xmlns:a16="http://schemas.microsoft.com/office/drawing/2014/main" xmlns="" val="10002"/>
                   </a:ext>
                 </a:extLst>
               </a:tr>
@@ -18166,7 +18232,7 @@
                 </a:tc>
                 <a:extLst>
                   <a:ext uri="{0D108BD9-81ED-4DB2-BD59-A6C34878D82A}">
-                    <a16:rowId xmlns:a16="http://schemas.microsoft.com/office/drawing/2014/main" val="10003"/>
+                    <a16:rowId xmlns:a16="http://schemas.microsoft.com/office/drawing/2014/main" xmlns="" val="10003"/>
                   </a:ext>
                 </a:extLst>
               </a:tr>
@@ -18303,7 +18369,7 @@
                 </a:tc>
                 <a:extLst>
                   <a:ext uri="{0D108BD9-81ED-4DB2-BD59-A6C34878D82A}">
-                    <a16:rowId xmlns:a16="http://schemas.microsoft.com/office/drawing/2014/main" val="10004"/>
+                    <a16:rowId xmlns:a16="http://schemas.microsoft.com/office/drawing/2014/main" xmlns="" val="10004"/>
                   </a:ext>
                 </a:extLst>
               </a:tr>
@@ -18440,7 +18506,7 @@
                 </a:tc>
                 <a:extLst>
                   <a:ext uri="{0D108BD9-81ED-4DB2-BD59-A6C34878D82A}">
-                    <a16:rowId xmlns:a16="http://schemas.microsoft.com/office/drawing/2014/main" val="10005"/>
+                    <a16:rowId xmlns:a16="http://schemas.microsoft.com/office/drawing/2014/main" xmlns="" val="10005"/>
                   </a:ext>
                 </a:extLst>
               </a:tr>
@@ -18577,7 +18643,7 @@
                 </a:tc>
                 <a:extLst>
                   <a:ext uri="{0D108BD9-81ED-4DB2-BD59-A6C34878D82A}">
-                    <a16:rowId xmlns:a16="http://schemas.microsoft.com/office/drawing/2014/main" val="10006"/>
+                    <a16:rowId xmlns:a16="http://schemas.microsoft.com/office/drawing/2014/main" xmlns="" val="10006"/>
                   </a:ext>
                 </a:extLst>
               </a:tr>
@@ -18714,7 +18780,7 @@
                 </a:tc>
                 <a:extLst>
                   <a:ext uri="{0D108BD9-81ED-4DB2-BD59-A6C34878D82A}">
-                    <a16:rowId xmlns:a16="http://schemas.microsoft.com/office/drawing/2014/main" val="10007"/>
+                    <a16:rowId xmlns:a16="http://schemas.microsoft.com/office/drawing/2014/main" xmlns="" val="10007"/>
                   </a:ext>
                 </a:extLst>
               </a:tr>
@@ -18851,7 +18917,7 @@
                 </a:tc>
                 <a:extLst>
                   <a:ext uri="{0D108BD9-81ED-4DB2-BD59-A6C34878D82A}">
-                    <a16:rowId xmlns:a16="http://schemas.microsoft.com/office/drawing/2014/main" val="10008"/>
+                    <a16:rowId xmlns:a16="http://schemas.microsoft.com/office/drawing/2014/main" xmlns="" val="10008"/>
                   </a:ext>
                 </a:extLst>
               </a:tr>
@@ -18988,7 +19054,7 @@
                 </a:tc>
                 <a:extLst>
                   <a:ext uri="{0D108BD9-81ED-4DB2-BD59-A6C34878D82A}">
-                    <a16:rowId xmlns:a16="http://schemas.microsoft.com/office/drawing/2014/main" val="10009"/>
+                    <a16:rowId xmlns:a16="http://schemas.microsoft.com/office/drawing/2014/main" xmlns="" val="10009"/>
                   </a:ext>
                 </a:extLst>
               </a:tr>
@@ -20081,21 +20147,21 @@
                 <a:gridCol w="2269375">
                   <a:extLst>
                     <a:ext uri="{9D8B030D-6E8A-4147-A177-3AD203B41FA5}">
-                      <a16:colId xmlns:a16="http://schemas.microsoft.com/office/drawing/2014/main" val="20000"/>
+                      <a16:colId xmlns:a16="http://schemas.microsoft.com/office/drawing/2014/main" xmlns="" val="20000"/>
                     </a:ext>
                   </a:extLst>
                 </a:gridCol>
                 <a:gridCol w="2425208">
                   <a:extLst>
                     <a:ext uri="{9D8B030D-6E8A-4147-A177-3AD203B41FA5}">
-                      <a16:colId xmlns:a16="http://schemas.microsoft.com/office/drawing/2014/main" val="20001"/>
+                      <a16:colId xmlns:a16="http://schemas.microsoft.com/office/drawing/2014/main" xmlns="" val="20001"/>
                     </a:ext>
                   </a:extLst>
                 </a:gridCol>
                 <a:gridCol w="3626457">
                   <a:extLst>
                     <a:ext uri="{9D8B030D-6E8A-4147-A177-3AD203B41FA5}">
-                      <a16:colId xmlns:a16="http://schemas.microsoft.com/office/drawing/2014/main" val="20002"/>
+                      <a16:colId xmlns:a16="http://schemas.microsoft.com/office/drawing/2014/main" xmlns="" val="20002"/>
                     </a:ext>
                   </a:extLst>
                 </a:gridCol>
@@ -20307,7 +20373,7 @@
                 </a:tc>
                 <a:extLst>
                   <a:ext uri="{0D108BD9-81ED-4DB2-BD59-A6C34878D82A}">
-                    <a16:rowId xmlns:a16="http://schemas.microsoft.com/office/drawing/2014/main" val="10000"/>
+                    <a16:rowId xmlns:a16="http://schemas.microsoft.com/office/drawing/2014/main" xmlns="" val="10000"/>
                   </a:ext>
                 </a:extLst>
               </a:tr>
@@ -20512,7 +20578,7 @@
                 </a:tc>
                 <a:extLst>
                   <a:ext uri="{0D108BD9-81ED-4DB2-BD59-A6C34878D82A}">
-                    <a16:rowId xmlns:a16="http://schemas.microsoft.com/office/drawing/2014/main" val="10001"/>
+                    <a16:rowId xmlns:a16="http://schemas.microsoft.com/office/drawing/2014/main" xmlns="" val="10001"/>
                   </a:ext>
                 </a:extLst>
               </a:tr>
@@ -20728,7 +20794,7 @@
                 </a:tc>
                 <a:extLst>
                   <a:ext uri="{0D108BD9-81ED-4DB2-BD59-A6C34878D82A}">
-                    <a16:rowId xmlns:a16="http://schemas.microsoft.com/office/drawing/2014/main" val="10002"/>
+                    <a16:rowId xmlns:a16="http://schemas.microsoft.com/office/drawing/2014/main" xmlns="" val="10002"/>
                   </a:ext>
                 </a:extLst>
               </a:tr>
@@ -20933,7 +20999,7 @@
                 </a:tc>
                 <a:extLst>
                   <a:ext uri="{0D108BD9-81ED-4DB2-BD59-A6C34878D82A}">
-                    <a16:rowId xmlns:a16="http://schemas.microsoft.com/office/drawing/2014/main" val="10003"/>
+                    <a16:rowId xmlns:a16="http://schemas.microsoft.com/office/drawing/2014/main" xmlns="" val="10003"/>
                   </a:ext>
                 </a:extLst>
               </a:tr>
@@ -21138,7 +21204,7 @@
                 </a:tc>
                 <a:extLst>
                   <a:ext uri="{0D108BD9-81ED-4DB2-BD59-A6C34878D82A}">
-                    <a16:rowId xmlns:a16="http://schemas.microsoft.com/office/drawing/2014/main" val="10004"/>
+                    <a16:rowId xmlns:a16="http://schemas.microsoft.com/office/drawing/2014/main" xmlns="" val="10004"/>
                   </a:ext>
                 </a:extLst>
               </a:tr>
@@ -21343,7 +21409,7 @@
                 </a:tc>
                 <a:extLst>
                   <a:ext uri="{0D108BD9-81ED-4DB2-BD59-A6C34878D82A}">
-                    <a16:rowId xmlns:a16="http://schemas.microsoft.com/office/drawing/2014/main" val="10005"/>
+                    <a16:rowId xmlns:a16="http://schemas.microsoft.com/office/drawing/2014/main" xmlns="" val="10005"/>
                   </a:ext>
                 </a:extLst>
               </a:tr>
@@ -24735,7 +24801,7 @@
         <p:cNvPr id="1" name="">
           <a:extLst>
             <a:ext uri="{FF2B5EF4-FFF2-40B4-BE49-F238E27FC236}">
-              <a16:creationId xmlns:a16="http://schemas.microsoft.com/office/drawing/2014/main" id="{934DA33B-A089-EED4-2DFE-5AF93D5DD888}"/>
+              <a16:creationId xmlns:a16="http://schemas.microsoft.com/office/drawing/2014/main" xmlns="" id="{934DA33B-A089-EED4-2DFE-5AF93D5DD888}"/>
             </a:ext>
           </a:extLst>
         </p:cNvPr>
@@ -24755,7 +24821,7 @@
           <p:cNvPr id="2" name="Shape 0">
             <a:extLst>
               <a:ext uri="{FF2B5EF4-FFF2-40B4-BE49-F238E27FC236}">
-                <a16:creationId xmlns:a16="http://schemas.microsoft.com/office/drawing/2014/main" id="{F59BECB2-5CC8-7222-89E2-75E45AF2028C}"/>
+                <a16:creationId xmlns:a16="http://schemas.microsoft.com/office/drawing/2014/main" xmlns="" id="{F59BECB2-5CC8-7222-89E2-75E45AF2028C}"/>
               </a:ext>
             </a:extLst>
           </p:cNvPr>
@@ -24793,7 +24859,7 @@
           <p:cNvPr id="3" name="Text 1">
             <a:extLst>
               <a:ext uri="{FF2B5EF4-FFF2-40B4-BE49-F238E27FC236}">
-                <a16:creationId xmlns:a16="http://schemas.microsoft.com/office/drawing/2014/main" id="{A224C6EC-B47C-8F50-3551-AF2381CE0850}"/>
+                <a16:creationId xmlns:a16="http://schemas.microsoft.com/office/drawing/2014/main" xmlns="" id="{A224C6EC-B47C-8F50-3551-AF2381CE0850}"/>
               </a:ext>
             </a:extLst>
           </p:cNvPr>
@@ -24838,7 +24904,7 @@
           <p:cNvPr id="4" name="Text 2">
             <a:extLst>
               <a:ext uri="{FF2B5EF4-FFF2-40B4-BE49-F238E27FC236}">
-                <a16:creationId xmlns:a16="http://schemas.microsoft.com/office/drawing/2014/main" id="{2141CBB7-1709-E31D-23BD-2BC6728E6745}"/>
+                <a16:creationId xmlns:a16="http://schemas.microsoft.com/office/drawing/2014/main" xmlns="" id="{2141CBB7-1709-E31D-23BD-2BC6728E6745}"/>
               </a:ext>
             </a:extLst>
           </p:cNvPr>
@@ -24872,7 +24938,7 @@
           <p:cNvPr id="27" name="Picture 26">
             <a:extLst>
               <a:ext uri="{FF2B5EF4-FFF2-40B4-BE49-F238E27FC236}">
-                <a16:creationId xmlns:a16="http://schemas.microsoft.com/office/drawing/2014/main" id="{AE006491-F032-E4A0-4109-2905383A302C}"/>
+                <a16:creationId xmlns:a16="http://schemas.microsoft.com/office/drawing/2014/main" xmlns="" id="{AE006491-F032-E4A0-4109-2905383A302C}"/>
               </a:ext>
             </a:extLst>
           </p:cNvPr>
@@ -29069,7 +29135,7 @@
         <p:cNvPr id="1" name="">
           <a:extLst>
             <a:ext uri="{FF2B5EF4-FFF2-40B4-BE49-F238E27FC236}">
-              <a16:creationId xmlns:a16="http://schemas.microsoft.com/office/drawing/2014/main" id="{80A788E6-EEB4-AEE3-6405-C342D467976B}"/>
+              <a16:creationId xmlns:a16="http://schemas.microsoft.com/office/drawing/2014/main" xmlns="" id="{80A788E6-EEB4-AEE3-6405-C342D467976B}"/>
             </a:ext>
           </a:extLst>
         </p:cNvPr>
@@ -29089,7 +29155,7 @@
           <p:cNvPr id="2" name="Shape 0">
             <a:extLst>
               <a:ext uri="{FF2B5EF4-FFF2-40B4-BE49-F238E27FC236}">
-                <a16:creationId xmlns:a16="http://schemas.microsoft.com/office/drawing/2014/main" id="{554BDE42-35EC-AB19-86AE-0F1E646E56BE}"/>
+                <a16:creationId xmlns:a16="http://schemas.microsoft.com/office/drawing/2014/main" xmlns="" id="{554BDE42-35EC-AB19-86AE-0F1E646E56BE}"/>
               </a:ext>
             </a:extLst>
           </p:cNvPr>
@@ -29127,7 +29193,7 @@
           <p:cNvPr id="3" name="Text 1">
             <a:extLst>
               <a:ext uri="{FF2B5EF4-FFF2-40B4-BE49-F238E27FC236}">
-                <a16:creationId xmlns:a16="http://schemas.microsoft.com/office/drawing/2014/main" id="{200F6773-9D8D-24A6-77AE-C59891D57618}"/>
+                <a16:creationId xmlns:a16="http://schemas.microsoft.com/office/drawing/2014/main" xmlns="" id="{200F6773-9D8D-24A6-77AE-C59891D57618}"/>
               </a:ext>
             </a:extLst>
           </p:cNvPr>
@@ -29169,7 +29235,7 @@
           <p:cNvPr id="4" name="Text 2">
             <a:extLst>
               <a:ext uri="{FF2B5EF4-FFF2-40B4-BE49-F238E27FC236}">
-                <a16:creationId xmlns:a16="http://schemas.microsoft.com/office/drawing/2014/main" id="{18D22E51-0DD1-1BB7-B3B3-56F2DF7599D1}"/>
+                <a16:creationId xmlns:a16="http://schemas.microsoft.com/office/drawing/2014/main" xmlns="" id="{18D22E51-0DD1-1BB7-B3B3-56F2DF7599D1}"/>
               </a:ext>
             </a:extLst>
           </p:cNvPr>
@@ -29203,7 +29269,7 @@
           <p:cNvPr id="25" name="Picture 24">
             <a:extLst>
               <a:ext uri="{FF2B5EF4-FFF2-40B4-BE49-F238E27FC236}">
-                <a16:creationId xmlns:a16="http://schemas.microsoft.com/office/drawing/2014/main" id="{B5DADA93-8C5C-C73D-A265-EB1C90BEB674}"/>
+                <a16:creationId xmlns:a16="http://schemas.microsoft.com/office/drawing/2014/main" xmlns="" id="{B5DADA93-8C5C-C73D-A265-EB1C90BEB674}"/>
               </a:ext>
             </a:extLst>
           </p:cNvPr>
@@ -29530,7 +29596,7 @@
   <a:extraClrSchemeLst/>
   <a:extLst>
     <a:ext uri="{05A4C25C-085E-4340-85A3-A5531E510DB2}">
-      <thm15:themeFamily xmlns:thm15="http://schemas.microsoft.com/office/thememl/2012/main" name="Office Theme" id="{62F939B6-93AF-4DB8-9C6B-D6C7DFDC589F}" vid="{4A3C46E8-61CC-4603-A589-7422A47A8E4A}"/>
+      <thm15:themeFamily xmlns:thm15="http://schemas.microsoft.com/office/thememl/2012/main" xmlns="" name="Office Theme" id="{62F939B6-93AF-4DB8-9C6B-D6C7DFDC589F}" vid="{4A3C46E8-61CC-4603-A589-7422A47A8E4A}"/>
     </a:ext>
   </a:extLst>
 </a:theme>
@@ -29825,7 +29891,7 @@
   <a:extraClrSchemeLst/>
   <a:extLst>
     <a:ext uri="{05A4C25C-085E-4340-85A3-A5531E510DB2}">
-      <thm15:themeFamily xmlns:thm15="http://schemas.microsoft.com/office/thememl/2012/main" name="Office Theme" id="{62F939B6-93AF-4DB8-9C6B-D6C7DFDC589F}" vid="{4A3C46E8-61CC-4603-A589-7422A47A8E4A}"/>
+      <thm15:themeFamily xmlns:thm15="http://schemas.microsoft.com/office/thememl/2012/main" xmlns="" name="Office Theme" id="{62F939B6-93AF-4DB8-9C6B-D6C7DFDC589F}" vid="{4A3C46E8-61CC-4603-A589-7422A47A8E4A}"/>
     </a:ext>
   </a:extLst>
 </a:theme>

</xml_diff>